<commit_message>
feat(dignitatis): nova identidade visual — paleta Terracota & Azul-Noite
- Reescreve brand_guidelines.md com nova identidade visual completa:
  paleta Terracota/Azul-Noite/Areia, tipografia Fraunces+Source Sans Pro,
  duas vozes (formal/acessível), hierarquia tipográfica e aplicações

- Atualiza gerar_documentos.py e gerar_odt.py com nova paleta e fontes
  (Terracota #B54E31, Azul-Noite #0F1F3D, Areia #F9F5EF)

- Regenera 7 templates de documentos (ofício, relatório, comunicado em
  .docx/.odt e apresentação .pptx) com nova identidade

- Adiciona 5 variantes de logomarca em assets/images/:
  completo, compacto, ícone, escuro (navy monocromático), branco
  (para fundos escuros), geradas via assets/images/gerar_logos.py

Nota: logo final (símbolo abstrato clima+direitos humanos) pendente de
aprovação — candidatos gerados no Canva aguardam escolha do usuário.

https://claude.ai/code/session_01WaLtJBgvbHVcf7ozv4GQmZ
</commit_message>
<xml_diff>
--- a/assets/templates/dignitatis_apresentacao.pptx
+++ b/assets/templates/dignitatis_apresentacao.pptx
@@ -3088,7 +3088,7 @@
     <p:bg>
       <p:bgPr>
         <a:solidFill>
-          <a:srgbClr val="2D3D2F"/>
+          <a:srgbClr val="0F1F3D"/>
         </a:solidFill>
         <a:effectLst/>
       </p:bgPr>
@@ -3115,7 +3115,7 @@
             <a:avLst/>
           </a:prstGeom>
           <a:solidFill>
-            <a:srgbClr val="4A7A5C"/>
+            <a:srgbClr val="B54E31"/>
           </a:solidFill>
           <a:ln>
             <a:noFill/>
@@ -3169,9 +3169,9 @@
             <a:r>
               <a:rPr sz="5400" b="1">
                 <a:solidFill>
-                  <a:srgbClr val="F4F1EB"/>
+                  <a:srgbClr val="F9F5EF"/>
                 </a:solidFill>
-                <a:latin typeface="Georgia"/>
+                <a:latin typeface="Fraunces"/>
               </a:rPr>
               <a:t>DIGNITATIS</a:t>
             </a:r>
@@ -3204,11 +3204,11 @@
             <a:r>
               <a:rPr sz="1300" b="0">
                 <a:solidFill>
-                  <a:srgbClr val="8C9E8C"/>
+                  <a:srgbClr val="9E8E7C"/>
                 </a:solidFill>
-                <a:latin typeface="Georgia"/>
+                <a:latin typeface="Fraunces"/>
               </a:rPr>
-              <a:t>Dignidade · Dignidad · Tekó Porã · Ọlá</a:t>
+              <a:t>Direitos Humanos · Paraíba · Brasil</a:t>
             </a:r>
           </a:p>
         </p:txBody>
@@ -3228,7 +3228,7 @@
             <a:avLst/>
           </a:prstGeom>
           <a:solidFill>
-            <a:srgbClr val="4A7A5C"/>
+            <a:srgbClr val="B54E31"/>
           </a:solidFill>
           <a:ln>
             <a:noFill/>
@@ -3282,9 +3282,9 @@
             <a:r>
               <a:rPr sz="2200" b="0">
                 <a:solidFill>
-                  <a:srgbClr val="F4F1EB"/>
+                  <a:srgbClr val="F9F5EF"/>
                 </a:solidFill>
-                <a:latin typeface="Calibri"/>
+                <a:latin typeface="Source Sans Pro"/>
               </a:rPr>
               <a:t>[Título da Apresentação]</a:t>
             </a:r>
@@ -3317,9 +3317,9 @@
             <a:r>
               <a:rPr sz="1400" b="0">
                 <a:solidFill>
-                  <a:srgbClr val="8C9E8C"/>
+                  <a:srgbClr val="9E8E7C"/>
                 </a:solidFill>
-                <a:latin typeface="Calibri"/>
+                <a:latin typeface="Source Sans Pro"/>
               </a:rPr>
               <a:t>[Subtítulo / Evento / Data]</a:t>
             </a:r>
@@ -3340,7 +3340,7 @@
     <p:bg>
       <p:bgPr>
         <a:solidFill>
-          <a:srgbClr val="F4F1EB"/>
+          <a:srgbClr val="F9F5EF"/>
         </a:solidFill>
         <a:effectLst/>
       </p:bgPr>
@@ -3367,7 +3367,7 @@
             <a:avLst/>
           </a:prstGeom>
           <a:solidFill>
-            <a:srgbClr val="4A7A5C"/>
+            <a:srgbClr val="B54E31"/>
           </a:solidFill>
           <a:ln>
             <a:noFill/>
@@ -3421,9 +3421,9 @@
             <a:r>
               <a:rPr sz="2800" b="1">
                 <a:solidFill>
-                  <a:srgbClr val="2D3D2F"/>
+                  <a:srgbClr val="0F1F3D"/>
                 </a:solidFill>
-                <a:latin typeface="Georgia"/>
+                <a:latin typeface="Fraunces"/>
               </a:rPr>
               <a:t>SUMÁRIO</a:t>
             </a:r>
@@ -3445,7 +3445,7 @@
             <a:avLst/>
           </a:prstGeom>
           <a:solidFill>
-            <a:srgbClr val="4A7A5C"/>
+            <a:srgbClr val="B54E31"/>
           </a:solidFill>
           <a:ln>
             <a:noFill/>
@@ -3501,7 +3501,7 @@
                 <a:solidFill>
                   <a:srgbClr val="1C1C1C"/>
                 </a:solidFill>
-                <a:latin typeface="Calibri"/>
+                <a:latin typeface="Source Sans Pro"/>
               </a:rPr>
               <a:t>01  Apresentação da Organização</a:t>
             </a:r>
@@ -3536,7 +3536,7 @@
                 <a:solidFill>
                   <a:srgbClr val="1C1C1C"/>
                 </a:solidFill>
-                <a:latin typeface="Calibri"/>
+                <a:latin typeface="Source Sans Pro"/>
               </a:rPr>
               <a:t>02  Contexto e Problema</a:t>
             </a:r>
@@ -3571,7 +3571,7 @@
                 <a:solidFill>
                   <a:srgbClr val="1C1C1C"/>
                 </a:solidFill>
-                <a:latin typeface="Calibri"/>
+                <a:latin typeface="Source Sans Pro"/>
               </a:rPr>
               <a:t>03  Nossa Atuação</a:t>
             </a:r>
@@ -3606,7 +3606,7 @@
                 <a:solidFill>
                   <a:srgbClr val="1C1C1C"/>
                 </a:solidFill>
-                <a:latin typeface="Calibri"/>
+                <a:latin typeface="Source Sans Pro"/>
               </a:rPr>
               <a:t>04  Resultados e Impacto</a:t>
             </a:r>
@@ -3641,7 +3641,7 @@
                 <a:solidFill>
                   <a:srgbClr val="1C1C1C"/>
                 </a:solidFill>
-                <a:latin typeface="Calibri"/>
+                <a:latin typeface="Source Sans Pro"/>
               </a:rPr>
               <a:t>05  Próximos Passos</a:t>
             </a:r>
@@ -3662,7 +3662,7 @@
     <p:bg>
       <p:bgPr>
         <a:solidFill>
-          <a:srgbClr val="F4F1EB"/>
+          <a:srgbClr val="F9F5EF"/>
         </a:solidFill>
         <a:effectLst/>
       </p:bgPr>
@@ -3689,7 +3689,7 @@
             <a:avLst/>
           </a:prstGeom>
           <a:solidFill>
-            <a:srgbClr val="4A7A5C"/>
+            <a:srgbClr val="B54E31"/>
           </a:solidFill>
           <a:ln>
             <a:noFill/>
@@ -3743,9 +3743,9 @@
             <a:r>
               <a:rPr sz="2800" b="1">
                 <a:solidFill>
-                  <a:srgbClr val="2D3D2F"/>
+                  <a:srgbClr val="0F1F3D"/>
                 </a:solidFill>
-                <a:latin typeface="Georgia"/>
+                <a:latin typeface="Fraunces"/>
               </a:rPr>
               <a:t>[Título da Seção]</a:t>
             </a:r>
@@ -3767,7 +3767,7 @@
             <a:avLst/>
           </a:prstGeom>
           <a:solidFill>
-            <a:srgbClr val="4A7A5C"/>
+            <a:srgbClr val="B54E31"/>
           </a:solidFill>
           <a:ln>
             <a:noFill/>
@@ -3823,7 +3823,7 @@
                 <a:solidFill>
                   <a:srgbClr val="1C1C1C"/>
                 </a:solidFill>
-                <a:latin typeface="Calibri"/>
+                <a:latin typeface="Source Sans Pro"/>
               </a:rPr>
               <a:t>• [Ponto principal 1]
 • [Ponto principal 2]
@@ -3848,7 +3848,7 @@
             <a:avLst/>
           </a:prstGeom>
           <a:solidFill>
-            <a:srgbClr val="4A7A5C"/>
+            <a:srgbClr val="B54E31"/>
           </a:solidFill>
           <a:ln>
             <a:noFill/>
@@ -3902,9 +3902,9 @@
             <a:r>
               <a:rPr sz="1800" b="0">
                 <a:solidFill>
-                  <a:srgbClr val="F4F1EB"/>
+                  <a:srgbClr val="F9F5EF"/>
                 </a:solidFill>
-                <a:latin typeface="Georgia"/>
+                <a:latin typeface="Fraunces"/>
               </a:rPr>
               <a:t>[Dado ou citação em destaque]</a:t>
             </a:r>
@@ -3925,7 +3925,7 @@
     <p:bg>
       <p:bgPr>
         <a:solidFill>
-          <a:srgbClr val="4A7A5C"/>
+          <a:srgbClr val="B54E31"/>
         </a:solidFill>
         <a:effectLst/>
       </p:bgPr>
@@ -3952,7 +3952,7 @@
             <a:avLst/>
           </a:prstGeom>
           <a:solidFill>
-            <a:srgbClr val="2D3D2F"/>
+            <a:srgbClr val="0F1F3D"/>
           </a:solidFill>
           <a:ln>
             <a:noFill/>
@@ -4006,9 +4006,9 @@
             <a:r>
               <a:rPr sz="9600" b="1">
                 <a:solidFill>
-                  <a:srgbClr val="F4F1EB"/>
+                  <a:srgbClr val="F9F5EF"/>
                 </a:solidFill>
-                <a:latin typeface="Georgia"/>
+                <a:latin typeface="Fraunces"/>
               </a:rPr>
               <a:t>“</a:t>
             </a:r>
@@ -4041,9 +4041,9 @@
             <a:r>
               <a:rPr sz="2200" b="0">
                 <a:solidFill>
-                  <a:srgbClr val="F4F1EB"/>
+                  <a:srgbClr val="F9F5EF"/>
                 </a:solidFill>
-                <a:latin typeface="Georgia"/>
+                <a:latin typeface="Fraunces"/>
               </a:rPr>
               <a:t>[Insira aqui uma citação impactante ou dado relevante sobre direitos humanos.]</a:t>
             </a:r>
@@ -4076,9 +4076,9 @@
             <a:r>
               <a:rPr sz="1300" b="0">
                 <a:solidFill>
-                  <a:srgbClr val="F4F1EB"/>
+                  <a:srgbClr val="F9F5EF"/>
                 </a:solidFill>
-                <a:latin typeface="Calibri"/>
+                <a:latin typeface="Source Sans Pro"/>
               </a:rPr>
               <a:t>— [Fonte / Autoria]</a:t>
             </a:r>
@@ -4099,7 +4099,7 @@
     <p:bg>
       <p:bgPr>
         <a:solidFill>
-          <a:srgbClr val="2D3D2F"/>
+          <a:srgbClr val="0F1F3D"/>
         </a:solidFill>
         <a:effectLst/>
       </p:bgPr>
@@ -4126,7 +4126,7 @@
             <a:avLst/>
           </a:prstGeom>
           <a:solidFill>
-            <a:srgbClr val="4A7A5C"/>
+            <a:srgbClr val="B54E31"/>
           </a:solidFill>
           <a:ln>
             <a:noFill/>
@@ -4180,9 +4180,9 @@
             <a:r>
               <a:rPr sz="4800" b="1">
                 <a:solidFill>
-                  <a:srgbClr val="F4F1EB"/>
+                  <a:srgbClr val="F9F5EF"/>
                 </a:solidFill>
-                <a:latin typeface="Georgia"/>
+                <a:latin typeface="Fraunces"/>
               </a:rPr>
               <a:t>Obrigado(a)</a:t>
             </a:r>
@@ -4204,7 +4204,7 @@
             <a:avLst/>
           </a:prstGeom>
           <a:solidFill>
-            <a:srgbClr val="4A7A5C"/>
+            <a:srgbClr val="B54E31"/>
           </a:solidFill>
           <a:ln>
             <a:noFill/>
@@ -4258,9 +4258,9 @@
             <a:r>
               <a:rPr sz="1800" b="1">
                 <a:solidFill>
-                  <a:srgbClr val="4A7A5C"/>
+                  <a:srgbClr val="B54E31"/>
                 </a:solidFill>
-                <a:latin typeface="Georgia"/>
+                <a:latin typeface="Fraunces"/>
               </a:rPr>
               <a:t>DIGNITATIS</a:t>
             </a:r>
@@ -4293,11 +4293,11 @@
             <a:r>
               <a:rPr sz="1100" b="0">
                 <a:solidFill>
-                  <a:srgbClr val="8C9E8C"/>
+                  <a:srgbClr val="9E8E7C"/>
                 </a:solidFill>
-                <a:latin typeface="Georgia"/>
+                <a:latin typeface="Fraunces"/>
               </a:rPr>
-              <a:t>Dignidade · Dignidad · Tekó Porã · Ọlá</a:t>
+              <a:t>Direitos Humanos · Paraíba · Brasil</a:t>
             </a:r>
           </a:p>
         </p:txBody>
@@ -4328,9 +4328,9 @@
             <a:r>
               <a:rPr sz="1200" b="0">
                 <a:solidFill>
-                  <a:srgbClr val="8C9E8C"/>
+                  <a:srgbClr val="9E8E7C"/>
                 </a:solidFill>
-                <a:latin typeface="Calibri"/>
+                <a:latin typeface="Source Sans Pro"/>
               </a:rPr>
               <a:t>[e-mail]  ·  [site]  ·  [redes sociais]</a:t>
             </a:r>

</xml_diff>